<commit_message>
YANA EOI loop 3: record owner answers, rebuild webform and slides, re-score
- Register: 25 Hume Ave in site (Lots 1-3 DP 713156 mapped), FSR 14.09:1
  owner-confirmed, storey count open with planner; OA-4..OA-7 not yet decided
- Webform and slides lead with 133.9 m and '38 residential storeys plus
  rooftop plant'; affordable basis left open; B-0/B-1/B-6 briefs corrected
- Scorecard: 2.1 GREEN, consistency AMBER; probabilities for locked and
  Variants A/B restated
- Listed new inputs not present and network still blocked; owner_decisions
  trimmed to open items

Co-Authored-By: Claude Opus 5.5 <noreply@anthropic.com>
Claude-Session: https://claude.ai/code/session_01QQtgY597ASLkYKgeaZD25L
</commit_message>
<xml_diff>
--- a/outputs/concept_slides.pptx
+++ b/outputs/concept_slides.pptx
@@ -119,67 +119,67 @@
   <p:extLst>
     <p:ext uri="{521415D9-36F7-43E2-AB2F-B90AF26B5E84}">
       <p14:sectionLst xmlns:p14="http://schemas.microsoft.com/office/powerpoint/2010/main">
-        <p14:section name="Cover" id="{bc83ede1-8179-e52c-ef8a-23258b0068bc}">
+        <p14:section name="Cover" id="{83e43a40-c66e-2a42-15f9-9ef4fab3cb94}">
           <p14:sldIdLst>
             <p14:sldId id="256"/>
           </p14:sldIdLst>
         </p14:section>
-        <p14:section name="Proposition" id="{7df891a8-dfc0-d2aa-8ed9-2dc9653ab271}">
+        <p14:section name="Proposition" id="{e839fbd2-aa52-cedf-c767-245873a4237f}">
           <p14:sldIdLst>
             <p14:sldId id="257"/>
           </p14:sldIdLst>
         </p14:section>
-        <p14:section name="Site and access" id="{3748cc1a-ffc0-0398-365c-14d77f074e7d}">
+        <p14:section name="Site and access" id="{45977af3-ec44-68c3-6551-d364c8a290b8}">
           <p14:sldIdLst>
             <p14:sldId id="258"/>
           </p14:sldIdLst>
         </p14:section>
-        <p14:section name="Strategic framework" id="{fa377e43-4b66-7d8f-395b-2253ad2a92ec}">
+        <p14:section name="Strategic framework" id="{1ca7c32c-269c-c1d2-2efc-c0d0922fa33a}">
           <p14:sldIdLst>
             <p14:sldId id="259"/>
           </p14:sldIdLst>
         </p14:section>
-        <p14:section name="Comparator board" id="{728d7ee5-3022-ccc0-49e1-6872d3aa8271}">
+        <p14:section name="Comparator board" id="{3a41e3fc-c605-8243-2c7a-bcd09f709a3c}">
           <p14:sldIdLst>
             <p14:sldId id="260"/>
           </p14:sldIdLst>
         </p14:section>
-        <p14:section name="Existing control vs proposal" id="{663d6a9b-1002-18ff-7b37-9471f91cd271}">
+        <p14:section name="Existing control vs proposal" id="{37000e43-faf0-42c0-26f2-f43f58a61570}">
           <p14:sldIdLst>
             <p14:sldId id="261"/>
           </p14:sldIdLst>
         </p14:section>
-        <p14:section name="Tower and podium form" id="{d7f7129b-7182-b57f-1014-431deae6eb33}">
+        <p14:section name="Tower and podium form" id="{3fc31694-87bf-90e3-5d49-2d9970514e82}">
           <p14:sldIdLst>
             <p14:sldId id="262"/>
           </p14:sldIdLst>
         </p14:section>
-        <p14:section name="Adjoining-site developability" id="{e56e7826-73c3-33bf-6c94-d07dcf232b65}">
+        <p14:section name="Adjoining-site developability" id="{e61d46b8-bf74-3e66-7feb-69f6669dc3cf}">
           <p14:sldIdLst>
             <p14:sldId id="263"/>
           </p14:sldIdLst>
         </p14:section>
-        <p14:section name="Impacts summary" id="{0c0542ce-f6d5-9451-32a1-21f70ab0c3c9}">
+        <p14:section name="Impacts summary" id="{4b26a355-de48-d4fa-4bca-3293c0c4626d}">
           <p14:sldIdLst>
             <p14:sldId id="264"/>
           </p14:sldIdLst>
         </p14:section>
-        <p14:section name="Housing and affordable housing" id="{1d3e39ee-0755-f7a3-be95-d4d4a09ca676}">
+        <p14:section name="Housing and affordable housing" id="{eb2aac80-697e-0239-1d30-0fa776ec37a1}">
           <p14:sldIdLst>
             <p14:sldId id="265"/>
           </p14:sldIdLst>
         </p14:section>
-        <p14:section name="Deliverability and programme" id="{d6e4620c-a2c6-0a55-805a-fbbae4a0e9c7}">
+        <p14:section name="Deliverability and programme" id="{f6845fb1-1a1e-44e7-f906-4b52f8ef7fa2}">
           <p14:sldIdLst>
             <p14:sldId id="266"/>
           </p14:sldIdLst>
         </p14:section>
-        <p14:section name="Why this pathway" id="{98b8b3af-d121-c89d-df8a-0f20a4617fc8}">
+        <p14:section name="Why this pathway" id="{641f146c-1938-a6af-02db-09201b614e7d}">
           <p14:sldIdLst>
             <p14:sldId id="267"/>
           </p14:sldIdLst>
         </p14:section>
-        <p14:section name="The ask" id="{e4ae14e1-d2ba-9f1a-8172-40b8668df581}">
+        <p14:section name="The ask" id="{45170ac6-2637-72a5-8a3a-a7b1429598c1}">
           <p14:sldIdLst>
             <p14:sldId id="268"/>
           </p14:sldIdLst>
@@ -967,7 +967,7 @@
           <a:p>
             <a:r>
               <a:rPr lang="en-US" dirty="0"/>
-              <a:t>Brief B-8 (Furtado Sullivan): Schedule of affordable dwellings equal to 3% of residential GFA (about 866 m²; confirm count), by level and type, shown on a stacking diagram. Distribute across at least three levels; same finishes and amenity access as market apartments. Basis (GFA vs dwellings) per OD-4.
+              <a:t>Brief B-8 (Furtado Sullivan): Schedule of affordable dwellings equal to 3% of residential GFA (about 866 m²; confirm count), by level and type, shown on a stacking diagram. Distribute across at least three levels; same finishes and amenity access as market apartments. Basis (GFA vs dwellings) not yet decided by the owner; show both counts.
 Indicative only — not for determination.</a:t>
             </a:r>
             <a:endParaRPr lang="en-US" dirty="0"/>
@@ -1853,7 +1853,7 @@
           <a:p>
             <a:r>
               <a:rPr lang="en-US" dirty="0"/>
-              <a:t>Brief B-6 (Furtado Sullivan / Arcadia): Plan and 3D massing showing a plausible residential envelope on each adjoining holding (81-87 Cecil Ave, 8,416 m²; the 2,600 m² lot to the south-west, address to be confirmed under OD-1), each meeting ADG building separation to YANA and achieving 2 hours mid-winter solar to 70% of its own apartments. State the assumed height and FSR for each and whether each meets cl 4.1A on its own. Include a mid-winter shadow overlay from YANA on both.
+              <a:t>Brief B-6 (Furtado Sullivan / Arcadia): Plan and 3D massing showing a plausible residential envelope on each adjoining holding (81-87 Cecil Ave, 8,416 m²; the 2,600 m² adjoining lot to the south-west — not 25 Hume Ave, which is part of the site (owner, 5 Oct 2026); confirm its address), each meeting ADG building separation to YANA and achieving 2 hours mid-winter solar to 70% of its own apartments. State the assumed height and FSR for each and whether each meets cl 4.1A on its own. Include a mid-winter shadow overlay from YANA on both.
 Indicative only — not for determination.</a:t>
             </a:r>
             <a:endParaRPr lang="en-US" dirty="0"/>
@@ -2069,7 +2069,7 @@
                   <a:schemeClr val="accent5"/>
                 </a:solidFill>
               </a:rPr>
-              <a:t>YANA · 77-79 Cecil Ave, Castle Hill · HDA EOI concept scheme · Indicative only, not for determination · DRAFT 5 Oct 2026</a:t>
+              <a:t>YANA · 77-79 Cecil Ave &amp; 25 Hume Ave, Castle Hill · HDA EOI concept scheme · Indicative only, not for determination · DRAFT 5 Oct 2026</a:t>
             </a:r>
             <a:endParaRPr lang="en-US" sz="1000" dirty="0"/>
           </a:p>
@@ -2224,7 +2224,7 @@
                   <a:schemeClr val="accent6"/>
                 </a:solidFill>
               </a:rPr>
-              <a:t>YANA · 77-79 Cecil Ave, Castle Hill · HDA EOI concept scheme · Indicative only, not for determination · DRAFT 5 Oct 2026</a:t>
+              <a:t>YANA · 77-79 Cecil Ave &amp; 25 Hume Ave, Castle Hill · HDA EOI concept scheme · Indicative only, not for determination · DRAFT 5 Oct 2026</a:t>
             </a:r>
             <a:endParaRPr lang="en-US" sz="1000" dirty="0"/>
           </a:p>
@@ -2648,7 +2648,7 @@
                   <a:schemeClr val="bg1"/>
                 </a:solidFill>
               </a:rPr>
-              <a:t>77-79 Cecil Avenue, Castle Hill · Dharug Country</a:t>
+              <a:t>77-79 Cecil Avenue &amp; 25 Hume Avenue, Castle Hill · Dharug Country</a:t>
             </a:r>
             <a:endParaRPr lang="en-US" sz="2400" dirty="0"/>
           </a:p>
@@ -2749,7 +2749,7 @@
                   <a:schemeClr val="bg1"/>
                 </a:solidFill>
               </a:rPr>
-              <a:t>Indicative only — not for determination. Draft for owner review, loop 2, 5 October 2026.</a:t>
+              <a:t>Indicative only — not for determination. Draft for owner review, loop 3, 5 October 2026.</a:t>
             </a:r>
             <a:endParaRPr lang="en-US" sz="1600" dirty="0"/>
           </a:p>
@@ -2815,7 +2815,7 @@
                 <a:ea typeface="Cambria" pitchFamily="34" charset="-122"/>
                 <a:cs typeface="Cambria" pitchFamily="34" charset="-120"/>
               </a:rPr>
-              <a:t>243 homes across six apartment types, with 3% of floor space held as affordable housing in perpetuity</a:t>
+              <a:t>243 homes across six apartment types, with 3% held as affordable housing in perpetuity</a:t>
             </a:r>
             <a:endParaRPr lang="en-US" sz="2600" dirty="0"/>
           </a:p>
@@ -3480,7 +3480,7 @@
                   <a:schemeClr val="tx1"/>
                 </a:solidFill>
               </a:rPr>
-              <a:t>3% of residential GFA (about 866 m², about 7 homes) as affordable rental in perpetuity, secured in the LEP amendment.</a:t>
+              <a:t>3% as affordable rental in perpetuity, secured in the LEP amendment: about 7 homes whether measured on GFA (about 866 m²) or on dwellings.</a:t>
             </a:r>
             <a:endParaRPr lang="en-US" sz="1400" dirty="0"/>
           </a:p>
@@ -3497,7 +3497,7 @@
                   <a:schemeClr val="accent5"/>
                 </a:solidFill>
               </a:rPr>
-              <a:t>Source: Locked position; count to confirm (B-8)</a:t>
+              <a:t>Source: Locked position; basis not yet decided (B-8)</a:t>
             </a:r>
             <a:endParaRPr lang="en-US" sz="1400" dirty="0"/>
           </a:p>
@@ -3613,7 +3613,7 @@
                   <a:schemeClr val="tx1"/>
                 </a:solidFill>
               </a:rPr>
-              <a:t>Community housing provider, dwelling schedule and distribution are to be confirmed.</a:t>
+              <a:t>Basis (GFA or dwellings), community housing provider, dwelling schedule and distribution are to be confirmed.</a:t>
             </a:r>
             <a:endParaRPr lang="en-US" sz="1400" dirty="0"/>
           </a:p>
@@ -3630,7 +3630,7 @@
                   <a:schemeClr val="accent5"/>
                 </a:solidFill>
               </a:rPr>
-              <a:t>Source: OD-4, OD-5</a:t>
+              <a:t>Source: Owner decision pending</a:t>
             </a:r>
             <a:endParaRPr lang="en-US" sz="1400" dirty="0"/>
           </a:p>
@@ -4661,7 +4661,7 @@
                   <a:schemeClr val="accent5"/>
                 </a:solidFill>
               </a:rPr>
-              <a:t>Source: OD-7</a:t>
+              <a:t>Source: Owner decision pending</a:t>
             </a:r>
             <a:endParaRPr lang="en-US" sz="1400" dirty="0"/>
           </a:p>
@@ -5941,7 +5941,7 @@
                 <a:ea typeface="Cambria" pitchFamily="34" charset="-122"/>
                 <a:cs typeface="Cambria" pitchFamily="34" charset="-120"/>
               </a:rPr>
-              <a:t>38</a:t>
+              <a:t>133.9 m</a:t>
             </a:r>
             <a:endParaRPr lang="en-US" sz="4000" dirty="0"/>
           </a:p>
@@ -5977,7 +5977,7 @@
                   <a:schemeClr val="tx1"/>
                 </a:solidFill>
               </a:rPr>
-              <a:t>storeys</a:t>
+              <a:t>height incl. 6 m tolerance</a:t>
             </a:r>
             <a:endParaRPr lang="en-US" sz="1200" dirty="0"/>
           </a:p>
@@ -6402,7 +6402,7 @@
                   <a:schemeClr val="tx1"/>
                 </a:solidFill>
               </a:rPr>
-              <a:t>A single tower on a podium with 28,865 m² gross floor area, retail at ground level and resident amenity on Level 1.</a:t>
+              <a:t>A single tower, 133.9 m including a 6 m design tolerance: 38 residential storeys plus rooftop plant on a podium. 28,865 m² GFA (14.09:1).</a:t>
             </a:r>
             <a:endParaRPr lang="en-US" sz="1400" dirty="0"/>
           </a:p>
@@ -6419,7 +6419,7 @@
                   <a:schemeClr val="accent5"/>
                 </a:solidFill>
               </a:rPr>
-              <a:t>Source: Pack p24</a:t>
+              <a:t>Source: Pack p24; storey count with planner</a:t>
             </a:r>
             <a:endParaRPr lang="en-US" sz="1400" dirty="0"/>
           </a:p>
@@ -7141,7 +7141,7 @@
                   <a:schemeClr val="tx1"/>
                 </a:solidFill>
               </a:rPr>
-              <a:t>Held in consolidated ownership — no further amalgamation required. Title evidence to follow.</a:t>
+              <a:t>Three lots, Lots 1-3 DP 713156 (25 Hume Ave, 79 Cecil Ave, 77 Cecil Ave), in consolidated ownership. No further amalgamation needed.</a:t>
             </a:r>
             <a:endParaRPr lang="en-US" sz="1400" dirty="0"/>
           </a:p>
@@ -7158,7 +7158,7 @@
                   <a:schemeClr val="accent5"/>
                 </a:solidFill>
               </a:rPr>
-              <a:t>Source: Pack p3; OD-1</a:t>
+              <a:t>Source: Pack p3; owner 5 Oct 2026; title evidence to follow</a:t>
             </a:r>
             <a:endParaRPr lang="en-US" sz="1400" dirty="0"/>
           </a:p>
@@ -9917,7 +9917,7 @@
                             <a:schemeClr val="tx1"/>
                           </a:solidFill>
                         </a:rPr>
-                        <a:t>YANA, 77-79 Cecil Ave</a:t>
+                        <a:t>YANA, 77-79 Cecil &amp; 25 Hume</a:t>
                       </a:r>
                       <a:endParaRPr lang="en-US" sz="1200" dirty="0"/>
                     </a:p>
@@ -9978,7 +9978,7 @@
                             <a:schemeClr val="tx1"/>
                           </a:solidFill>
                         </a:rPr>
-                        <a:t>38</a:t>
+                        <a:t>38 + plant</a:t>
                       </a:r>
                       <a:endParaRPr lang="en-US" sz="1200" dirty="0"/>
                     </a:p>
@@ -12221,7 +12221,7 @@
                   <a:schemeClr val="tx1"/>
                 </a:solidFill>
               </a:rPr>
-              <a:t>Draft site study shows indicative footprints on 81-87 Cecil Ave (8,416 m²) and a 2,600 m² lot to the south-west.</a:t>
+              <a:t>Draft site study shows indicative footprints on 81-87 Cecil Ave (8,416 m²) and a 2,600 m² adjoining lot to the south-west.</a:t>
             </a:r>
             <a:endParaRPr lang="en-US" sz="1400" dirty="0"/>
           </a:p>
@@ -12238,7 +12238,7 @@
                   <a:schemeClr val="accent5"/>
                 </a:solidFill>
               </a:rPr>
-              <a:t>Source: Pack p23 (marked DRAFT)</a:t>
+              <a:t>Source: Pack p23 (marked DRAFT; site red line to be corrected, B-0)</a:t>
             </a:r>
             <a:endParaRPr lang="en-US" sz="1400" dirty="0"/>
           </a:p>
@@ -12490,7 +12490,7 @@
                   <a:schemeClr val="accent5"/>
                 </a:solidFill>
               </a:rPr>
-              <a:t>Source: Brief B-6; OD-1</a:t>
+              <a:t>Source: Brief B-6</a:t>
             </a:r>
             <a:endParaRPr lang="en-US" sz="1400" dirty="0"/>
           </a:p>

</xml_diff>

<commit_message>
Loop 4: read HDA criteria, form and records from source; rebuild webform on live Q1-Q60; re-score
- Ingest s10.7 certificate for 79 Cecil Ave (Jan 2023, Lot 2)
- Research log sections h-l: criteria V2, questions V3, live form, 15 Jun / 18 Aug / 15 Sep 2026 records, Castle Hill SSD pages, Sydney Plan, LMR
- Webform restructured to the live form; hazards, contributions, in-fill bonus and strategic merit answers redrafted
- Scorecard: 4.2 marked decisive; hazards, 4.1 and isolation upgraded; upload compliance added
- Owner decisions D-1 to D-5; slides rebuilt

Co-Authored-By: Claude Opus 5.5 <noreply@anthropic.com>
Claude-Session: https://claude.ai/code/session_01MLRz8PJdA68XgmYrHNt5YA
</commit_message>
<xml_diff>
--- a/outputs/concept_slides.pptx
+++ b/outputs/concept_slides.pptx
@@ -119,67 +119,67 @@
   <p:extLst>
     <p:ext uri="{521415D9-36F7-43E2-AB2F-B90AF26B5E84}">
       <p14:sectionLst xmlns:p14="http://schemas.microsoft.com/office/powerpoint/2010/main">
-        <p14:section name="Cover" id="{83e43a40-c66e-2a42-15f9-9ef4fab3cb94}">
+        <p14:section name="Cover" id="{5a9dc763-6753-3aa4-3c9f-90934fc78d83}">
           <p14:sldIdLst>
             <p14:sldId id="256"/>
           </p14:sldIdLst>
         </p14:section>
-        <p14:section name="Proposition" id="{e839fbd2-aa52-cedf-c767-245873a4237f}">
+        <p14:section name="Proposition" id="{17d5d520-8c89-f239-195c-d48dae9ae5d5}">
           <p14:sldIdLst>
             <p14:sldId id="257"/>
           </p14:sldIdLst>
         </p14:section>
-        <p14:section name="Site and access" id="{45977af3-ec44-68c3-6551-d364c8a290b8}">
+        <p14:section name="Site and access" id="{00a6afad-b0c0-0786-fbb8-0ea2aace1fa1}">
           <p14:sldIdLst>
             <p14:sldId id="258"/>
           </p14:sldIdLst>
         </p14:section>
-        <p14:section name="Strategic framework" id="{1ca7c32c-269c-c1d2-2efc-c0d0922fa33a}">
+        <p14:section name="Strategic framework" id="{7884169c-79fc-08e6-cfa9-1328a4f6ba00}">
           <p14:sldIdLst>
             <p14:sldId id="259"/>
           </p14:sldIdLst>
         </p14:section>
-        <p14:section name="Comparator board" id="{3a41e3fc-c605-8243-2c7a-bcd09f709a3c}">
+        <p14:section name="Comparator board" id="{fe5d650e-64a7-abd0-a97b-937f31e3906a}">
           <p14:sldIdLst>
             <p14:sldId id="260"/>
           </p14:sldIdLst>
         </p14:section>
-        <p14:section name="Existing control vs proposal" id="{37000e43-faf0-42c0-26f2-f43f58a61570}">
+        <p14:section name="Existing control vs proposal" id="{e98d2e5e-079c-991f-bec0-c5130c600404}">
           <p14:sldIdLst>
             <p14:sldId id="261"/>
           </p14:sldIdLst>
         </p14:section>
-        <p14:section name="Tower and podium form" id="{3fc31694-87bf-90e3-5d49-2d9970514e82}">
+        <p14:section name="Tower and podium form" id="{0e84c31c-c778-6d01-caba-ccbcc4d87bcf}">
           <p14:sldIdLst>
             <p14:sldId id="262"/>
           </p14:sldIdLst>
         </p14:section>
-        <p14:section name="Adjoining-site developability" id="{e61d46b8-bf74-3e66-7feb-69f6669dc3cf}">
+        <p14:section name="Adjoining-site developability" id="{b84d92e5-5c17-3808-0e4b-0524d5120131}">
           <p14:sldIdLst>
             <p14:sldId id="263"/>
           </p14:sldIdLst>
         </p14:section>
-        <p14:section name="Impacts summary" id="{4b26a355-de48-d4fa-4bca-3293c0c4626d}">
+        <p14:section name="Impacts summary" id="{345cf23a-ecbb-dd58-7356-d55124900a04}">
           <p14:sldIdLst>
             <p14:sldId id="264"/>
           </p14:sldIdLst>
         </p14:section>
-        <p14:section name="Housing and affordable housing" id="{eb2aac80-697e-0239-1d30-0fa776ec37a1}">
+        <p14:section name="Housing and affordable housing" id="{0ea84b10-0d06-ecd2-bbed-618a870b4d62}">
           <p14:sldIdLst>
             <p14:sldId id="265"/>
           </p14:sldIdLst>
         </p14:section>
-        <p14:section name="Deliverability and programme" id="{f6845fb1-1a1e-44e7-f906-4b52f8ef7fa2}">
+        <p14:section name="Deliverability and programme" id="{1c2257fc-d511-ad7d-b819-58817648de7d}">
           <p14:sldIdLst>
             <p14:sldId id="266"/>
           </p14:sldIdLst>
         </p14:section>
-        <p14:section name="Why this pathway" id="{641f146c-1938-a6af-02db-09201b614e7d}">
+        <p14:section name="Why this pathway" id="{fd22f8b9-34ba-6aa7-eafe-e7aca77c7860}">
           <p14:sldIdLst>
             <p14:sldId id="267"/>
           </p14:sldIdLst>
         </p14:section>
-        <p14:section name="The ask" id="{45170ac6-2637-72a5-8a3a-a7b1429598c1}">
+        <p14:section name="The ask" id="{1a90bba0-cef1-c5f5-e602-198b2c66d877}">
           <p14:sldIdLst>
             <p14:sldId id="268"/>
           </p14:sldIdLst>
@@ -322,7 +322,7 @@
                     <c:v>LEP control</c:v>
                   </c:pt>
                   <c:pt idx="1">
-                    <c:v>In-fill bonus</c:v>
+                    <c:v>LMR + in-fill bonus</c:v>
                   </c:pt>
                   <c:pt idx="2">
                     <c:v>Proposal</c:v>
@@ -341,7 +341,7 @@
                   <c:v>16</c:v>
                 </c:pt>
                 <c:pt idx="1">
-                  <c:v>20.8</c:v>
+                  <c:v>22.75</c:v>
                 </c:pt>
                 <c:pt idx="2">
                   <c:v>133.9</c:v>
@@ -1408,7 +1408,7 @@
           <a:p>
             <a:r>
               <a:rPr lang="en-US" dirty="0"/>
-              <a:t>Brief B-2 (Urbis / Arcadia): 1:5,000 at A3. Shortest public pedestrian route from the site's nearest pedestrian entry point to the nearest Castle Hill Metro station entrance, measured along footpaths and crossings, with the distance annotated (pack states about 623 m). State both end points and the date measured. Show the 400 m and 800 m walking catchments and the bus stop on Old Northern Road (routes 600, 603, 610X).
+              <a:t>Brief B-2 (Planner / Arcadia): 1:5,000 at A3. Shortest public pedestrian route from the site's nearest pedestrian entry point to the nearest Castle Hill Metro station entrance, measured along footpaths and crossings, with the distance annotated (pack states about 623 m). State both end points and the date measured. Show the 400 m and 800 m walking catchments and the bus stop on Old Northern Road (routes 600, 603, 610X).
 Indicative only — not for determination.</a:t>
             </a:r>
             <a:endParaRPr lang="en-US" dirty="0"/>
@@ -1586,7 +1586,7 @@
           <a:p>
             <a:r>
               <a:rPr lang="en-US" dirty="0"/>
-              <a:t>Brief B-5 (Furtado Sullivan / Arcadia): One axonometric of the Castle Hill centre from the south-east, showing YANA and only schemes whose height is confirmed from a primary source at drafting: 16-20 Old Castle Hill Rd (40 storeys), 325-329 Old Northern Rd (25 storeys / 83.6 m), 2-4 &amp; 22-28 Garthowen Cres (up to 36 storeys), 93-107 Cecil Ave (height per DPHI portal), Castle Hill Metro. Label each with storeys, status (declared / SSD lodged / proposed) and source. Do not show 'potential uplift' or TOD envelopes.
+              <a:t>Brief B-5 (Furtado Sullivan / Arcadia): One axonometric of the Castle Hill centre from the south-east, showing YANA and only schemes whose height is confirmed from a primary source at drafting: 16-20 Old Castle Hill Rd (40 storeys), 244-248 Old Northern Rd (height per its SEARs request), 2-4 &amp; 22-28 Garthowen Cres (up to 36 storeys), 93-107 Cecil Ave (23 to 35 storeys, per DPHI portal), Castle Hill Metro. Label each with storeys, status (declared / SSD lodged / proposed) and source. Do not show 'potential uplift' or TOD envelopes.
 Indicative only — not for determination.</a:t>
             </a:r>
             <a:endParaRPr lang="en-US" dirty="0"/>
@@ -1675,7 +1675,7 @@
           <a:p>
             <a:r>
               <a:rPr lang="en-US" dirty="0"/>
-              <a:t>Brief B-3 (Furtado Sullivan): Two street elevations (Cecil Ave and Hume Ave) at 1:1,000, same scale, side by side. Draw: the 16 m LEP height plane; the in-fill affordable housing bonus plane at about 20.8 m (Urbis to confirm); the proposal to top of plant (RL 248.90, 127.9 m) and to the 6 m design-tolerance envelope (RL 254.90, 133.9 m). Label RLs, storeys and ground RL 121.00. No rendering; line drawing with a single tone for the proposal.
+              <a:t>Brief B-3 (Furtado Sullivan): Two street elevations (Cecil Ave and Hume Ave) at 1:1,000, same scale, side by side. Draw: the 16 m LEP height plane; the Low and Mid-Rise standard plus in-fill bonus plane at 22.75 m (planner to confirm inner or outer area); the proposal to top of plant (RL 248.90, 127.9 m) and to the 6 m design-tolerance envelope (RL 254.90, 133.9 m). Label RLs, storeys and ground RL 121.00. No rendering; line drawing with a single tone for the proposal.
 Indicative only — not for determination.</a:t>
             </a:r>
             <a:endParaRPr lang="en-US" dirty="0"/>
@@ -2069,7 +2069,7 @@
                   <a:schemeClr val="accent5"/>
                 </a:solidFill>
               </a:rPr>
-              <a:t>YANA · 77-79 Cecil Ave &amp; 25 Hume Ave, Castle Hill · HDA EOI concept scheme · Indicative only, not for determination · DRAFT 5 Oct 2026</a:t>
+              <a:t>YANA · 77-79 Cecil Ave &amp; 25 Hume Ave, Castle Hill · HDA EOI concept scheme · Indicative only, not for determination · DRAFT 7 Oct 2026</a:t>
             </a:r>
             <a:endParaRPr lang="en-US" sz="1000" dirty="0"/>
           </a:p>
@@ -2224,7 +2224,7 @@
                   <a:schemeClr val="accent6"/>
                 </a:solidFill>
               </a:rPr>
-              <a:t>YANA · 77-79 Cecil Ave &amp; 25 Hume Ave, Castle Hill · HDA EOI concept scheme · Indicative only, not for determination · DRAFT 5 Oct 2026</a:t>
+              <a:t>YANA · 77-79 Cecil Ave &amp; 25 Hume Ave, Castle Hill · HDA EOI concept scheme · Indicative only, not for determination · DRAFT 7 Oct 2026</a:t>
             </a:r>
             <a:endParaRPr lang="en-US" sz="1000" dirty="0"/>
           </a:p>
@@ -2749,7 +2749,7 @@
                   <a:schemeClr val="bg1"/>
                 </a:solidFill>
               </a:rPr>
-              <a:t>Indicative only — not for determination. Draft for owner review, loop 3, 5 October 2026.</a:t>
+              <a:t>Indicative only — not for determination. Draft for owner review, loop 4, 7 October 2026.</a:t>
             </a:r>
             <a:endParaRPr lang="en-US" sz="1600" dirty="0"/>
           </a:p>
@@ -4772,7 +4772,7 @@
                 <a:ea typeface="Cambria" pitchFamily="34" charset="-122"/>
                 <a:cs typeface="Cambria" pitchFamily="34" charset="-120"/>
               </a:rPr>
-              <a:t>Only a concurrent rezoning can test this envelope; the in-fill bonus reaches about six storeys</a:t>
+              <a:t>No other State pathway delivers this housing: the in-fill bonus yields fewer than 50 homes</a:t>
             </a:r>
             <a:endParaRPr lang="en-US" sz="2600" dirty="0"/>
           </a:p>
@@ -4910,7 +4910,7 @@
                   <a:schemeClr val="tx1"/>
                 </a:solidFill>
               </a:rPr>
-              <a:t>In-fill bonus: up to +30% height for 15% affordable for 15 years. On this site, about 20.8 m.</a:t>
+              <a:t>In-fill bonus on the Low and Mid-Rise standard: 22.75 m and 1.95:1, about 34 homes; at most 28.6 m and 2.86:1, about 49 homes. Both are under the 100-home State significance threshold.</a:t>
             </a:r>
             <a:endParaRPr lang="en-US" sz="1400" dirty="0"/>
           </a:p>
@@ -4927,7 +4927,7 @@
                   <a:schemeClr val="accent5"/>
                 </a:solidFill>
               </a:rPr>
-              <a:t>Source: R-f2 (Urbis to verify)</a:t>
+              <a:t>Source: Research log section l; planner to confirm</a:t>
             </a:r>
             <a:endParaRPr lang="en-US" sz="1400" dirty="0"/>
           </a:p>
@@ -5281,7 +5281,7 @@
                   <a:schemeClr val="tx1"/>
                 </a:solidFill>
               </a:rPr>
-              <a:t>Status of council's draft Castle Hill Precinct Plan to be confirmed at lodgement.</a:t>
+              <a:t>The right height for this site is a matter for merit assessment; a lower outcome than proposed is accepted as possible.</a:t>
             </a:r>
             <a:endParaRPr lang="en-US" sz="1400" dirty="0"/>
           </a:p>
@@ -5298,7 +5298,7 @@
                   <a:schemeClr val="accent5"/>
                 </a:solidFill>
               </a:rPr>
-              <a:t>Source: R-f3; CA-4</a:t>
+              <a:t>Source: Owner to approve</a:t>
             </a:r>
             <a:endParaRPr lang="en-US" sz="1400" dirty="0"/>
           </a:p>
@@ -7256,7 +7256,7 @@
                   <a:schemeClr val="tx1"/>
                 </a:solidFill>
               </a:rPr>
-              <a:t>To: Urbis / Arcadia</a:t>
+              <a:t>To: Planner / Arcadia</a:t>
             </a:r>
             <a:endParaRPr lang="en-US" sz="1100" dirty="0"/>
           </a:p>
@@ -7539,7 +7539,7 @@
                   <a:schemeClr val="accent5"/>
                 </a:solidFill>
               </a:rPr>
-              <a:t>Source: R-e1 (to verify)</a:t>
+              <a:t>Source: R-k1</a:t>
             </a:r>
             <a:endParaRPr lang="en-US" sz="1400" dirty="0"/>
           </a:p>
@@ -7777,7 +7777,7 @@
                   <a:schemeClr val="accent5"/>
                 </a:solidFill>
               </a:rPr>
-              <a:t>Source: R-g1 (to verify)</a:t>
+              <a:t>Source: R-k6</a:t>
             </a:r>
             <a:endParaRPr lang="en-US" sz="1400" dirty="0"/>
           </a:p>
@@ -7990,7 +7990,7 @@
                 <a:ea typeface="Cambria" pitchFamily="34" charset="-122"/>
                 <a:cs typeface="Cambria" pitchFamily="34" charset="-120"/>
               </a:rPr>
-              <a:t>Castle Hill already has towers of 25 to 40 storeys in the State pipeline</a:t>
+              <a:t>Castle Hill already has towers of up to 40 storeys in the State pipeline</a:t>
             </a:r>
             <a:endParaRPr lang="en-US" sz="2600" dirty="0"/>
           </a:p>
@@ -8689,7 +8689,7 @@
                             <a:schemeClr val="tx1"/>
                           </a:solidFill>
                         </a:rPr>
-                        <a:t>Declared; EIS exhibited Oct 2026</a:t>
+                        <a:t>Declared; EIS exhibited 1-15 Oct 2026</a:t>
                       </a:r>
                       <a:endParaRPr lang="en-US" sz="1200" dirty="0"/>
                     </a:p>
@@ -8750,7 +8750,7 @@
                             <a:schemeClr val="tx1"/>
                           </a:solidFill>
                         </a:rPr>
-                        <a:t>R-c1</a:t>
+                        <a:t>R-j5</a:t>
                       </a:r>
                       <a:endParaRPr lang="en-US" sz="1200" dirty="0"/>
                     </a:p>
@@ -8996,7 +8996,7 @@
                             <a:schemeClr val="tx1"/>
                           </a:solidFill>
                         </a:rPr>
-                        <a:t>15% of GFA</a:t>
+                        <a:t>15% of GFA, 15 years</a:t>
                       </a:r>
                       <a:endParaRPr lang="en-US" sz="1200" dirty="0"/>
                     </a:p>
@@ -9057,7 +9057,7 @@
                             <a:schemeClr val="tx1"/>
                           </a:solidFill>
                         </a:rPr>
-                        <a:t>HDA briefing</a:t>
+                        <a:t>Recommended 15 Jun 2026</a:t>
                       </a:r>
                       <a:endParaRPr lang="en-US" sz="1200" dirty="0"/>
                     </a:p>
@@ -9118,7 +9118,7 @@
                             <a:schemeClr val="tx1"/>
                           </a:solidFill>
                         </a:rPr>
-                        <a:t>Pack p17</a:t>
+                        <a:t>R-j3</a:t>
                       </a:r>
                       <a:endParaRPr lang="en-US" sz="1200" dirty="0"/>
                     </a:p>
@@ -9549,7 +9549,7 @@
                             <a:schemeClr val="tx1"/>
                           </a:solidFill>
                         </a:rPr>
-                        <a:t>325-329 Old Northern Rd</a:t>
+                        <a:t>93-107 Cecil Ave &amp; 9-10 Roger Ave</a:t>
                       </a:r>
                       <a:endParaRPr lang="en-US" sz="1200" dirty="0"/>
                     </a:p>
@@ -9610,7 +9610,7 @@
                             <a:schemeClr val="tx1"/>
                           </a:solidFill>
                         </a:rPr>
-                        <a:t>25</a:t>
+                        <a:t>23 to 35</a:t>
                       </a:r>
                       <a:endParaRPr lang="en-US" sz="1200" dirty="0"/>
                     </a:p>
@@ -9671,7 +9671,7 @@
                             <a:schemeClr val="tx1"/>
                           </a:solidFill>
                         </a:rPr>
-                        <a:t>148</a:t>
+                        <a:t>610</a:t>
                       </a:r>
                       <a:endParaRPr lang="en-US" sz="1200" dirty="0"/>
                     </a:p>
@@ -9732,7 +9732,7 @@
                             <a:schemeClr val="tx1"/>
                           </a:solidFill>
                         </a:rPr>
-                        <a:t>5%, in perpetuity</a:t>
+                        <a:t>117 homes</a:t>
                       </a:r>
                       <a:endParaRPr lang="en-US" sz="1200" dirty="0"/>
                     </a:p>
@@ -9793,7 +9793,7 @@
                             <a:schemeClr val="tx1"/>
                           </a:solidFill>
                         </a:rPr>
-                        <a:t>SSD proposed</a:t>
+                        <a:t>SSD under assessment</a:t>
                       </a:r>
                       <a:endParaRPr lang="en-US" sz="1200" dirty="0"/>
                     </a:p>
@@ -9854,7 +9854,375 @@
                             <a:schemeClr val="tx1"/>
                           </a:solidFill>
                         </a:rPr>
-                        <a:t>R-c5</a:t>
+                        <a:t>Owner, Sep 2026</a:t>
+                      </a:r>
+                      <a:endParaRPr lang="en-US" sz="1200" dirty="0"/>
+                    </a:p>
+                  </a:txBody>
+                  <a:tcPr marL="54864" marR="54864" marT="54864" marB="54864" anchor="ctr">
+                    <a:lnL w="6350" cap="flat" cmpd="sng" algn="ctr">
+                      <a:solidFill>
+                        <a:srgbClr val="C9D3C5"/>
+                      </a:solidFill>
+                      <a:prstDash val="solid"/>
+                      <a:round/>
+                      <a:headEnd type="none" w="med" len="med"/>
+                      <a:tailEnd type="none" w="med" len="med"/>
+                    </a:lnL>
+                    <a:lnR w="6350" cap="flat" cmpd="sng" algn="ctr">
+                      <a:solidFill>
+                        <a:srgbClr val="C9D3C5"/>
+                      </a:solidFill>
+                      <a:prstDash val="solid"/>
+                      <a:round/>
+                      <a:headEnd type="none" w="med" len="med"/>
+                      <a:tailEnd type="none" w="med" len="med"/>
+                    </a:lnR>
+                    <a:lnT w="6350" cap="flat" cmpd="sng" algn="ctr">
+                      <a:solidFill>
+                        <a:srgbClr val="C9D3C5"/>
+                      </a:solidFill>
+                      <a:prstDash val="solid"/>
+                      <a:round/>
+                      <a:headEnd type="none" w="med" len="med"/>
+                      <a:tailEnd type="none" w="med" len="med"/>
+                    </a:lnT>
+                    <a:lnB w="6350" cap="flat" cmpd="sng" algn="ctr">
+                      <a:solidFill>
+                        <a:srgbClr val="C9D3C5"/>
+                      </a:solidFill>
+                      <a:prstDash val="solid"/>
+                      <a:round/>
+                      <a:headEnd type="none" w="med" len="med"/>
+                      <a:tailEnd type="none" w="med" len="med"/>
+                    </a:lnB>
+                    <a:solidFill>
+                      <a:schemeClr val="bg1"/>
+                    </a:solidFill>
+                  </a:tcPr>
+                </a:tc>
+              </a:tr>
+              <a:tr h="0">
+                <a:tc>
+                  <a:txBody>
+                    <a:bodyPr/>
+                    <a:lstStyle/>
+                    <a:p>
+                      <a:pPr indent="0" marL="0">
+                        <a:buNone/>
+                      </a:pPr>
+                      <a:r>
+                        <a:rPr lang="en-US" sz="1200" dirty="0">
+                          <a:solidFill>
+                            <a:schemeClr val="tx1"/>
+                          </a:solidFill>
+                        </a:rPr>
+                        <a:t>244-248 Old Northern Rd</a:t>
+                      </a:r>
+                      <a:endParaRPr lang="en-US" sz="1200" dirty="0"/>
+                    </a:p>
+                  </a:txBody>
+                  <a:tcPr marL="54864" marR="54864" marT="54864" marB="54864" anchor="ctr">
+                    <a:lnL w="6350" cap="flat" cmpd="sng" algn="ctr">
+                      <a:solidFill>
+                        <a:srgbClr val="C9D3C5"/>
+                      </a:solidFill>
+                      <a:prstDash val="solid"/>
+                      <a:round/>
+                      <a:headEnd type="none" w="med" len="med"/>
+                      <a:tailEnd type="none" w="med" len="med"/>
+                    </a:lnL>
+                    <a:lnR w="6350" cap="flat" cmpd="sng" algn="ctr">
+                      <a:solidFill>
+                        <a:srgbClr val="C9D3C5"/>
+                      </a:solidFill>
+                      <a:prstDash val="solid"/>
+                      <a:round/>
+                      <a:headEnd type="none" w="med" len="med"/>
+                      <a:tailEnd type="none" w="med" len="med"/>
+                    </a:lnR>
+                    <a:lnT w="6350" cap="flat" cmpd="sng" algn="ctr">
+                      <a:solidFill>
+                        <a:srgbClr val="C9D3C5"/>
+                      </a:solidFill>
+                      <a:prstDash val="solid"/>
+                      <a:round/>
+                      <a:headEnd type="none" w="med" len="med"/>
+                      <a:tailEnd type="none" w="med" len="med"/>
+                    </a:lnT>
+                    <a:lnB w="6350" cap="flat" cmpd="sng" algn="ctr">
+                      <a:solidFill>
+                        <a:srgbClr val="C9D3C5"/>
+                      </a:solidFill>
+                      <a:prstDash val="solid"/>
+                      <a:round/>
+                      <a:headEnd type="none" w="med" len="med"/>
+                      <a:tailEnd type="none" w="med" len="med"/>
+                    </a:lnB>
+                    <a:solidFill>
+                      <a:schemeClr val="bg1"/>
+                    </a:solidFill>
+                  </a:tcPr>
+                </a:tc>
+                <a:tc>
+                  <a:txBody>
+                    <a:bodyPr/>
+                    <a:lstStyle/>
+                    <a:p>
+                      <a:pPr indent="0" marL="0">
+                        <a:buNone/>
+                      </a:pPr>
+                      <a:r>
+                        <a:rPr lang="en-US" sz="1200" dirty="0">
+                          <a:solidFill>
+                            <a:schemeClr val="tx1"/>
+                          </a:solidFill>
+                        </a:rPr>
+                        <a:t>not stated</a:t>
+                      </a:r>
+                      <a:endParaRPr lang="en-US" sz="1200" dirty="0"/>
+                    </a:p>
+                  </a:txBody>
+                  <a:tcPr marL="54864" marR="54864" marT="54864" marB="54864" anchor="ctr">
+                    <a:lnL w="6350" cap="flat" cmpd="sng" algn="ctr">
+                      <a:solidFill>
+                        <a:srgbClr val="C9D3C5"/>
+                      </a:solidFill>
+                      <a:prstDash val="solid"/>
+                      <a:round/>
+                      <a:headEnd type="none" w="med" len="med"/>
+                      <a:tailEnd type="none" w="med" len="med"/>
+                    </a:lnL>
+                    <a:lnR w="6350" cap="flat" cmpd="sng" algn="ctr">
+                      <a:solidFill>
+                        <a:srgbClr val="C9D3C5"/>
+                      </a:solidFill>
+                      <a:prstDash val="solid"/>
+                      <a:round/>
+                      <a:headEnd type="none" w="med" len="med"/>
+                      <a:tailEnd type="none" w="med" len="med"/>
+                    </a:lnR>
+                    <a:lnT w="6350" cap="flat" cmpd="sng" algn="ctr">
+                      <a:solidFill>
+                        <a:srgbClr val="C9D3C5"/>
+                      </a:solidFill>
+                      <a:prstDash val="solid"/>
+                      <a:round/>
+                      <a:headEnd type="none" w="med" len="med"/>
+                      <a:tailEnd type="none" w="med" len="med"/>
+                    </a:lnT>
+                    <a:lnB w="6350" cap="flat" cmpd="sng" algn="ctr">
+                      <a:solidFill>
+                        <a:srgbClr val="C9D3C5"/>
+                      </a:solidFill>
+                      <a:prstDash val="solid"/>
+                      <a:round/>
+                      <a:headEnd type="none" w="med" len="med"/>
+                      <a:tailEnd type="none" w="med" len="med"/>
+                    </a:lnB>
+                    <a:solidFill>
+                      <a:schemeClr val="bg1"/>
+                    </a:solidFill>
+                  </a:tcPr>
+                </a:tc>
+                <a:tc>
+                  <a:txBody>
+                    <a:bodyPr/>
+                    <a:lstStyle/>
+                    <a:p>
+                      <a:pPr indent="0" marL="0">
+                        <a:buNone/>
+                      </a:pPr>
+                      <a:r>
+                        <a:rPr lang="en-US" sz="1200" dirty="0">
+                          <a:solidFill>
+                            <a:schemeClr val="tx1"/>
+                          </a:solidFill>
+                        </a:rPr>
+                        <a:t>up to 200</a:t>
+                      </a:r>
+                      <a:endParaRPr lang="en-US" sz="1200" dirty="0"/>
+                    </a:p>
+                  </a:txBody>
+                  <a:tcPr marL="54864" marR="54864" marT="54864" marB="54864" anchor="ctr">
+                    <a:lnL w="6350" cap="flat" cmpd="sng" algn="ctr">
+                      <a:solidFill>
+                        <a:srgbClr val="C9D3C5"/>
+                      </a:solidFill>
+                      <a:prstDash val="solid"/>
+                      <a:round/>
+                      <a:headEnd type="none" w="med" len="med"/>
+                      <a:tailEnd type="none" w="med" len="med"/>
+                    </a:lnL>
+                    <a:lnR w="6350" cap="flat" cmpd="sng" algn="ctr">
+                      <a:solidFill>
+                        <a:srgbClr val="C9D3C5"/>
+                      </a:solidFill>
+                      <a:prstDash val="solid"/>
+                      <a:round/>
+                      <a:headEnd type="none" w="med" len="med"/>
+                      <a:tailEnd type="none" w="med" len="med"/>
+                    </a:lnR>
+                    <a:lnT w="6350" cap="flat" cmpd="sng" algn="ctr">
+                      <a:solidFill>
+                        <a:srgbClr val="C9D3C5"/>
+                      </a:solidFill>
+                      <a:prstDash val="solid"/>
+                      <a:round/>
+                      <a:headEnd type="none" w="med" len="med"/>
+                      <a:tailEnd type="none" w="med" len="med"/>
+                    </a:lnT>
+                    <a:lnB w="6350" cap="flat" cmpd="sng" algn="ctr">
+                      <a:solidFill>
+                        <a:srgbClr val="C9D3C5"/>
+                      </a:solidFill>
+                      <a:prstDash val="solid"/>
+                      <a:round/>
+                      <a:headEnd type="none" w="med" len="med"/>
+                      <a:tailEnd type="none" w="med" len="med"/>
+                    </a:lnB>
+                    <a:solidFill>
+                      <a:schemeClr val="bg1"/>
+                    </a:solidFill>
+                  </a:tcPr>
+                </a:tc>
+                <a:tc>
+                  <a:txBody>
+                    <a:bodyPr/>
+                    <a:lstStyle/>
+                    <a:p>
+                      <a:pPr indent="0" marL="0">
+                        <a:buNone/>
+                      </a:pPr>
+                      <a:r>
+                        <a:rPr lang="en-US" sz="1200" dirty="0">
+                          <a:solidFill>
+                            <a:schemeClr val="tx1"/>
+                          </a:solidFill>
+                        </a:rPr>
+                        <a:t>10%</a:t>
+                      </a:r>
+                      <a:endParaRPr lang="en-US" sz="1200" dirty="0"/>
+                    </a:p>
+                  </a:txBody>
+                  <a:tcPr marL="54864" marR="54864" marT="54864" marB="54864" anchor="ctr">
+                    <a:lnL w="6350" cap="flat" cmpd="sng" algn="ctr">
+                      <a:solidFill>
+                        <a:srgbClr val="C9D3C5"/>
+                      </a:solidFill>
+                      <a:prstDash val="solid"/>
+                      <a:round/>
+                      <a:headEnd type="none" w="med" len="med"/>
+                      <a:tailEnd type="none" w="med" len="med"/>
+                    </a:lnL>
+                    <a:lnR w="6350" cap="flat" cmpd="sng" algn="ctr">
+                      <a:solidFill>
+                        <a:srgbClr val="C9D3C5"/>
+                      </a:solidFill>
+                      <a:prstDash val="solid"/>
+                      <a:round/>
+                      <a:headEnd type="none" w="med" len="med"/>
+                      <a:tailEnd type="none" w="med" len="med"/>
+                    </a:lnR>
+                    <a:lnT w="6350" cap="flat" cmpd="sng" algn="ctr">
+                      <a:solidFill>
+                        <a:srgbClr val="C9D3C5"/>
+                      </a:solidFill>
+                      <a:prstDash val="solid"/>
+                      <a:round/>
+                      <a:headEnd type="none" w="med" len="med"/>
+                      <a:tailEnd type="none" w="med" len="med"/>
+                    </a:lnT>
+                    <a:lnB w="6350" cap="flat" cmpd="sng" algn="ctr">
+                      <a:solidFill>
+                        <a:srgbClr val="C9D3C5"/>
+                      </a:solidFill>
+                      <a:prstDash val="solid"/>
+                      <a:round/>
+                      <a:headEnd type="none" w="med" len="med"/>
+                      <a:tailEnd type="none" w="med" len="med"/>
+                    </a:lnB>
+                    <a:solidFill>
+                      <a:schemeClr val="bg1"/>
+                    </a:solidFill>
+                  </a:tcPr>
+                </a:tc>
+                <a:tc>
+                  <a:txBody>
+                    <a:bodyPr/>
+                    <a:lstStyle/>
+                    <a:p>
+                      <a:pPr indent="0" marL="0">
+                        <a:buNone/>
+                      </a:pPr>
+                      <a:r>
+                        <a:rPr lang="en-US" sz="1200" dirty="0">
+                          <a:solidFill>
+                            <a:schemeClr val="tx1"/>
+                          </a:solidFill>
+                        </a:rPr>
+                        <a:t>Declared; preparing EIS</a:t>
+                      </a:r>
+                      <a:endParaRPr lang="en-US" sz="1200" dirty="0"/>
+                    </a:p>
+                  </a:txBody>
+                  <a:tcPr marL="54864" marR="54864" marT="54864" marB="54864" anchor="ctr">
+                    <a:lnL w="6350" cap="flat" cmpd="sng" algn="ctr">
+                      <a:solidFill>
+                        <a:srgbClr val="C9D3C5"/>
+                      </a:solidFill>
+                      <a:prstDash val="solid"/>
+                      <a:round/>
+                      <a:headEnd type="none" w="med" len="med"/>
+                      <a:tailEnd type="none" w="med" len="med"/>
+                    </a:lnL>
+                    <a:lnR w="6350" cap="flat" cmpd="sng" algn="ctr">
+                      <a:solidFill>
+                        <a:srgbClr val="C9D3C5"/>
+                      </a:solidFill>
+                      <a:prstDash val="solid"/>
+                      <a:round/>
+                      <a:headEnd type="none" w="med" len="med"/>
+                      <a:tailEnd type="none" w="med" len="med"/>
+                    </a:lnR>
+                    <a:lnT w="6350" cap="flat" cmpd="sng" algn="ctr">
+                      <a:solidFill>
+                        <a:srgbClr val="C9D3C5"/>
+                      </a:solidFill>
+                      <a:prstDash val="solid"/>
+                      <a:round/>
+                      <a:headEnd type="none" w="med" len="med"/>
+                      <a:tailEnd type="none" w="med" len="med"/>
+                    </a:lnT>
+                    <a:lnB w="6350" cap="flat" cmpd="sng" algn="ctr">
+                      <a:solidFill>
+                        <a:srgbClr val="C9D3C5"/>
+                      </a:solidFill>
+                      <a:prstDash val="solid"/>
+                      <a:round/>
+                      <a:headEnd type="none" w="med" len="med"/>
+                      <a:tailEnd type="none" w="med" len="med"/>
+                    </a:lnB>
+                    <a:solidFill>
+                      <a:schemeClr val="bg1"/>
+                    </a:solidFill>
+                  </a:tcPr>
+                </a:tc>
+                <a:tc>
+                  <a:txBody>
+                    <a:bodyPr/>
+                    <a:lstStyle/>
+                    <a:p>
+                      <a:pPr indent="0" marL="0">
+                        <a:buNone/>
+                      </a:pPr>
+                      <a:r>
+                        <a:rPr lang="en-US" sz="1200" dirty="0">
+                          <a:solidFill>
+                            <a:schemeClr val="tx1"/>
+                          </a:solidFill>
+                        </a:rPr>
+                        <a:t>R-j6</a:t>
                       </a:r>
                       <a:endParaRPr lang="en-US" sz="1200" dirty="0"/>
                     </a:p>
@@ -10370,7 +10738,7 @@
                   <a:schemeClr val="tx1"/>
                 </a:solidFill>
               </a:rPr>
-              <a:t>All comparator figures are from search-located records, to be verified against DPHI sources before lodgement.</a:t>
+              <a:t>Rows marked R-j were read from DPHI and Planning Portal pages on 7 October 2026. The planner is to check every row before lodgement.</a:t>
             </a:r>
             <a:endParaRPr lang="en-US" sz="1400" dirty="0"/>
           </a:p>
@@ -10387,7 +10755,7 @@
                   <a:schemeClr val="accent5"/>
                 </a:solidFill>
               </a:rPr>
-              <a:t>Source: CA-0</a:t>
+              <a:t>Source: Research log section j</a:t>
             </a:r>
             <a:endParaRPr lang="en-US" sz="1400" dirty="0"/>
           </a:p>
@@ -10870,7 +11238,7 @@
                   <a:schemeClr val="tx1"/>
                 </a:solidFill>
               </a:rPr>
-              <a:t>The in-fill affordable housing bonus adds up to 30% height, to about 20.8 m.</a:t>
+              <a:t>Low and Mid-Rise housing standards apply around Castle Hill: 17.5 m at this distance. The in-fill affordable housing bonus adds 30%, to 22.75 m.</a:t>
             </a:r>
             <a:endParaRPr lang="en-US" sz="1400" dirty="0"/>
           </a:p>
@@ -10887,7 +11255,7 @@
                   <a:schemeClr val="accent5"/>
                 </a:solidFill>
               </a:rPr>
-              <a:t>Source: R-f2 (Urbis to verify)</a:t>
+              <a:t>Source: R-k2, R-k3; planner to confirm inner or outer area</a:t>
             </a:r>
             <a:endParaRPr lang="en-US" sz="1400" dirty="0"/>
           </a:p>
@@ -13092,7 +13460,7 @@
                   <a:schemeClr val="tx1"/>
                 </a:solidFill>
               </a:rPr>
-              <a:t>Flood, bushfire and contamination status not yet confirmed.</a:t>
+              <a:t>79 Cecil Ave: not in the flood planning area, not bush fire prone, no contamination or landslip policy applies.</a:t>
             </a:r>
             <a:endParaRPr lang="en-US" sz="1400" dirty="0"/>
           </a:p>
@@ -13109,7 +13477,7 @@
                   <a:schemeClr val="accent5"/>
                 </a:solidFill>
               </a:rPr>
-              <a:t>Source: s10.7 certificate outstanding (CA-3)</a:t>
+              <a:t>Source: s10.7 cert 121562, Jan 2023; current certificates for all three lots to follow</a:t>
             </a:r>
             <a:endParaRPr lang="en-US" sz="1400" dirty="0"/>
           </a:p>

</xml_diff>